<commit_message>
Add LLM integration: Claude agents, .env setup, updated docs
- Wire all 6 agents and Feedback Agent to Claude Haiku via Anthropic SDK
- Graceful keyword-scoring fallback when ANTHROPIC_API_KEY is absent
- Add backend/.env.example with setup instructions
- Pass recommendations array from frontend to /api/refine endpoint
- Update README: tech stack table, Commands section, Known Limitations
- Refresh slide.js: 5-step flow, CTDL live-data badge, .docx export bar
- Regenerated demo slide PPTX

Co-Authored-By: Claude Sonnet 4.6 <noreply@anthropic.com>
</commit_message>
<xml_diff>
--- a/Faculty Co-Design Demo Slide.pptx
+++ b/Faculty Co-Design Demo Slide.pptx
@@ -1082,7 +1082,7 @@
         </p:nvSpPr>
         <p:spPr>
           <a:xfrm>
-            <a:off x="347472" y="1581912"/>
+            <a:off x="347472" y="1508760"/>
             <a:ext cx="301752" cy="301752"/>
           </a:xfrm>
           <a:prstGeom prst="ellipse">
@@ -1107,7 +1107,7 @@
         </p:nvSpPr>
         <p:spPr>
           <a:xfrm>
-            <a:off x="347472" y="1581912"/>
+            <a:off x="347472" y="1508760"/>
             <a:ext cx="301752" cy="301752"/>
           </a:xfrm>
           <a:prstGeom prst="rect">
@@ -1146,8 +1146,8 @@
         </p:nvSpPr>
         <p:spPr>
           <a:xfrm>
-            <a:off x="731520" y="1600200"/>
-            <a:ext cx="1984248" cy="274320"/>
+            <a:off x="731520" y="1527048"/>
+            <a:ext cx="1984248" cy="292608"/>
           </a:xfrm>
           <a:prstGeom prst="rect">
             <a:avLst/>
@@ -1163,7 +1163,7 @@
               <a:buNone/>
             </a:pPr>
             <a:r>
-              <a:rPr lang="en-US" sz="1200" dirty="0">
+              <a:rPr lang="en-US" sz="1150" dirty="0">
                 <a:solidFill>
                   <a:srgbClr val="1A202C"/>
                 </a:solidFill>
@@ -1171,9 +1171,9 @@
                 <a:ea typeface="Calibri" pitchFamily="34" charset="-122"/>
                 <a:cs typeface="Calibri" pitchFamily="34" charset="-120"/>
               </a:rPr>
-              <a:t>Faculty uploads syllabus</a:t>
-            </a:r>
-            <a:endParaRPr lang="en-US" sz="1200" dirty="0"/>
+              <a:t>Faculty submits syllabus</a:t>
+            </a:r>
+            <a:endParaRPr lang="en-US" sz="1150" dirty="0"/>
           </a:p>
         </p:txBody>
       </p:sp>
@@ -1185,8 +1185,8 @@
         </p:nvSpPr>
         <p:spPr>
           <a:xfrm>
-            <a:off x="498348" y="1883664"/>
-            <a:ext cx="0" cy="356616"/>
+            <a:off x="498348" y="1810512"/>
+            <a:ext cx="0" cy="219456"/>
           </a:xfrm>
           <a:prstGeom prst="line">
             <a:avLst/>
@@ -1208,7 +1208,7 @@
         </p:nvSpPr>
         <p:spPr>
           <a:xfrm>
-            <a:off x="347472" y="2240280"/>
+            <a:off x="347472" y="2029968"/>
             <a:ext cx="301752" cy="301752"/>
           </a:xfrm>
           <a:prstGeom prst="ellipse">
@@ -1233,7 +1233,7 @@
         </p:nvSpPr>
         <p:spPr>
           <a:xfrm>
-            <a:off x="347472" y="2240280"/>
+            <a:off x="347472" y="2029968"/>
             <a:ext cx="301752" cy="301752"/>
           </a:xfrm>
           <a:prstGeom prst="rect">
@@ -1272,8 +1272,8 @@
         </p:nvSpPr>
         <p:spPr>
           <a:xfrm>
-            <a:off x="731520" y="2258568"/>
-            <a:ext cx="1984248" cy="274320"/>
+            <a:off x="731520" y="2048256"/>
+            <a:ext cx="1984248" cy="292608"/>
           </a:xfrm>
           <a:prstGeom prst="rect">
             <a:avLst/>
@@ -1289,7 +1289,7 @@
               <a:buNone/>
             </a:pPr>
             <a:r>
-              <a:rPr lang="en-US" sz="1200" dirty="0">
+              <a:rPr lang="en-US" sz="1150" dirty="0">
                 <a:solidFill>
                   <a:srgbClr val="1A202C"/>
                 </a:solidFill>
@@ -1299,7 +1299,7 @@
               </a:rPr>
               <a:t>6 AI agents analyze in parallel</a:t>
             </a:r>
-            <a:endParaRPr lang="en-US" sz="1200" dirty="0"/>
+            <a:endParaRPr lang="en-US" sz="1150" dirty="0"/>
           </a:p>
         </p:txBody>
       </p:sp>
@@ -1311,8 +1311,8 @@
         </p:nvSpPr>
         <p:spPr>
           <a:xfrm>
-            <a:off x="498348" y="2542032"/>
-            <a:ext cx="0" cy="356616"/>
+            <a:off x="498348" y="2331720"/>
+            <a:ext cx="0" cy="219456"/>
           </a:xfrm>
           <a:prstGeom prst="line">
             <a:avLst/>
@@ -1334,7 +1334,7 @@
         </p:nvSpPr>
         <p:spPr>
           <a:xfrm>
-            <a:off x="347472" y="2898648"/>
+            <a:off x="347472" y="2551176"/>
             <a:ext cx="301752" cy="301752"/>
           </a:xfrm>
           <a:prstGeom prst="ellipse">
@@ -1359,7 +1359,7 @@
         </p:nvSpPr>
         <p:spPr>
           <a:xfrm>
-            <a:off x="347472" y="2898648"/>
+            <a:off x="347472" y="2551176"/>
             <a:ext cx="301752" cy="301752"/>
           </a:xfrm>
           <a:prstGeom prst="rect">
@@ -1398,8 +1398,8 @@
         </p:nvSpPr>
         <p:spPr>
           <a:xfrm>
-            <a:off x="731520" y="2916936"/>
-            <a:ext cx="1984248" cy="274320"/>
+            <a:off x="731520" y="2569464"/>
+            <a:ext cx="1984248" cy="292608"/>
           </a:xfrm>
           <a:prstGeom prst="rect">
             <a:avLst/>
@@ -1415,7 +1415,7 @@
               <a:buNone/>
             </a:pPr>
             <a:r>
-              <a:rPr lang="en-US" sz="1200" dirty="0">
+              <a:rPr lang="en-US" sz="1150" dirty="0">
                 <a:solidFill>
                   <a:srgbClr val="1A202C"/>
                 </a:solidFill>
@@ -1423,9 +1423,9 @@
                 <a:ea typeface="Calibri" pitchFamily="34" charset="-122"/>
                 <a:cs typeface="Calibri" pitchFamily="34" charset="-120"/>
               </a:rPr>
-              <a:t>Feedback Agent prioritizes findings</a:t>
-            </a:r>
-            <a:endParaRPr lang="en-US" sz="1200" dirty="0"/>
+              <a:t>Feedback Agent ranks findings</a:t>
+            </a:r>
+            <a:endParaRPr lang="en-US" sz="1150" dirty="0"/>
           </a:p>
         </p:txBody>
       </p:sp>
@@ -1437,8 +1437,8 @@
         </p:nvSpPr>
         <p:spPr>
           <a:xfrm>
-            <a:off x="498348" y="3200400"/>
-            <a:ext cx="0" cy="356616"/>
+            <a:off x="498348" y="2852928"/>
+            <a:ext cx="0" cy="219456"/>
           </a:xfrm>
           <a:prstGeom prst="line">
             <a:avLst/>
@@ -1460,18 +1460,18 @@
         </p:nvSpPr>
         <p:spPr>
           <a:xfrm>
-            <a:off x="347472" y="3557016"/>
+            <a:off x="347472" y="3072384"/>
             <a:ext cx="301752" cy="301752"/>
           </a:xfrm>
           <a:prstGeom prst="ellipse">
             <a:avLst/>
           </a:prstGeom>
           <a:solidFill>
-            <a:srgbClr val="60A5FA"/>
+            <a:srgbClr val="16A34A"/>
           </a:solidFill>
           <a:ln w="12700">
             <a:solidFill>
-              <a:srgbClr val="60A5FA"/>
+              <a:srgbClr val="16A34A"/>
             </a:solidFill>
             <a:prstDash val="solid"/>
           </a:ln>
@@ -1485,7 +1485,7 @@
         </p:nvSpPr>
         <p:spPr>
           <a:xfrm>
-            <a:off x="347472" y="3557016"/>
+            <a:off x="347472" y="3072384"/>
             <a:ext cx="301752" cy="301752"/>
           </a:xfrm>
           <a:prstGeom prst="rect">
@@ -1524,8 +1524,8 @@
         </p:nvSpPr>
         <p:spPr>
           <a:xfrm>
-            <a:off x="731520" y="3575304"/>
-            <a:ext cx="1984248" cy="274320"/>
+            <a:off x="731520" y="3090672"/>
+            <a:ext cx="1984248" cy="292608"/>
           </a:xfrm>
           <a:prstGeom prst="rect">
             <a:avLst/>
@@ -1541,7 +1541,7 @@
               <a:buNone/>
             </a:pPr>
             <a:r>
-              <a:rPr lang="en-US" sz="1200" dirty="0">
+              <a:rPr lang="en-US" sz="1150" dirty="0">
                 <a:solidFill>
                   <a:srgbClr val="1A202C"/>
                 </a:solidFill>
@@ -1549,15 +1549,141 @@
                 <a:ea typeface="Calibri" pitchFamily="34" charset="-122"/>
                 <a:cs typeface="Calibri" pitchFamily="34" charset="-120"/>
               </a:rPr>
-              <a:t>Faculty reviews inline suggestions</a:t>
-            </a:r>
-            <a:endParaRPr lang="en-US" sz="1200" dirty="0"/>
+              <a:t>Select recs → get revision steps</a:t>
+            </a:r>
+            <a:endParaRPr lang="en-US" sz="1150" dirty="0"/>
           </a:p>
         </p:txBody>
       </p:sp>
       <p:sp>
         <p:nvSpPr>
           <p:cNvPr id="23" name="Shape 21"/>
+          <p:cNvSpPr/>
+          <p:nvPr/>
+        </p:nvSpPr>
+        <p:spPr>
+          <a:xfrm>
+            <a:off x="498348" y="3374136"/>
+            <a:ext cx="0" cy="219456"/>
+          </a:xfrm>
+          <a:prstGeom prst="line">
+            <a:avLst/>
+          </a:prstGeom>
+          <a:noFill/>
+          <a:ln w="12700">
+            <a:solidFill>
+              <a:srgbClr val="CBD5E1"/>
+            </a:solidFill>
+            <a:prstDash val="dash"/>
+          </a:ln>
+        </p:spPr>
+      </p:sp>
+      <p:sp>
+        <p:nvSpPr>
+          <p:cNvPr id="24" name="Shape 22"/>
+          <p:cNvSpPr/>
+          <p:nvPr/>
+        </p:nvSpPr>
+        <p:spPr>
+          <a:xfrm>
+            <a:off x="347472" y="3593592"/>
+            <a:ext cx="301752" cy="301752"/>
+          </a:xfrm>
+          <a:prstGeom prst="ellipse">
+            <a:avLst/>
+          </a:prstGeom>
+          <a:solidFill>
+            <a:srgbClr val="15803D"/>
+          </a:solidFill>
+          <a:ln w="12700">
+            <a:solidFill>
+              <a:srgbClr val="15803D"/>
+            </a:solidFill>
+            <a:prstDash val="solid"/>
+          </a:ln>
+        </p:spPr>
+      </p:sp>
+      <p:sp>
+        <p:nvSpPr>
+          <p:cNvPr id="25" name="Text 23"/>
+          <p:cNvSpPr/>
+          <p:nvPr/>
+        </p:nvSpPr>
+        <p:spPr>
+          <a:xfrm>
+            <a:off x="347472" y="3593592"/>
+            <a:ext cx="301752" cy="301752"/>
+          </a:xfrm>
+          <a:prstGeom prst="rect">
+            <a:avLst/>
+          </a:prstGeom>
+          <a:noFill/>
+          <a:ln/>
+        </p:spPr>
+        <p:txBody>
+          <a:bodyPr wrap="square" lIns="0" tIns="0" rIns="0" bIns="0" rtlCol="0" anchor="ctr"/>
+          <a:lstStyle/>
+          <a:p>
+            <a:pPr algn="ctr" indent="0" marL="0">
+              <a:buNone/>
+            </a:pPr>
+            <a:r>
+              <a:rPr lang="en-US" sz="1100" b="1" dirty="0">
+                <a:solidFill>
+                  <a:srgbClr val="FFFFFF"/>
+                </a:solidFill>
+                <a:latin typeface="Calibri" pitchFamily="34" charset="0"/>
+                <a:ea typeface="Calibri" pitchFamily="34" charset="-122"/>
+                <a:cs typeface="Calibri" pitchFamily="34" charset="-120"/>
+              </a:rPr>
+              <a:t>5</a:t>
+            </a:r>
+            <a:endParaRPr lang="en-US" sz="1100" dirty="0"/>
+          </a:p>
+        </p:txBody>
+      </p:sp>
+      <p:sp>
+        <p:nvSpPr>
+          <p:cNvPr id="26" name="Text 24"/>
+          <p:cNvSpPr/>
+          <p:nvPr/>
+        </p:nvSpPr>
+        <p:spPr>
+          <a:xfrm>
+            <a:off x="731520" y="3611880"/>
+            <a:ext cx="1984248" cy="292608"/>
+          </a:xfrm>
+          <a:prstGeom prst="rect">
+            <a:avLst/>
+          </a:prstGeom>
+          <a:noFill/>
+          <a:ln/>
+        </p:spPr>
+        <p:txBody>
+          <a:bodyPr wrap="square" lIns="0" tIns="0" rIns="0" bIns="0" rtlCol="0" anchor="ctr"/>
+          <a:lstStyle/>
+          <a:p>
+            <a:pPr indent="0" marL="0">
+              <a:buNone/>
+            </a:pPr>
+            <a:r>
+              <a:rPr lang="en-US" sz="1150" dirty="0">
+                <a:solidFill>
+                  <a:srgbClr val="1A202C"/>
+                </a:solidFill>
+                <a:latin typeface="Calibri" pitchFamily="34" charset="0"/>
+                <a:ea typeface="Calibri" pitchFamily="34" charset="-122"/>
+                <a:cs typeface="Calibri" pitchFamily="34" charset="-120"/>
+              </a:rPr>
+              <a:t>Export targeted edits to .docx</a:t>
+            </a:r>
+            <a:endParaRPr lang="en-US" sz="1150" dirty="0"/>
+          </a:p>
+        </p:txBody>
+      </p:sp>
+      <p:sp>
+        <p:nvSpPr>
+          <p:cNvPr id="27" name="Shape 25"/>
           <p:cNvSpPr/>
           <p:nvPr/>
         </p:nvSpPr>
@@ -1589,7 +1715,7 @@
       </p:sp>
       <p:sp>
         <p:nvSpPr>
-          <p:cNvPr id="24" name="Shape 22"/>
+          <p:cNvPr id="28" name="Shape 26"/>
           <p:cNvSpPr/>
           <p:nvPr/>
         </p:nvSpPr>
@@ -1614,7 +1740,7 @@
       </p:sp>
       <p:sp>
         <p:nvSpPr>
-          <p:cNvPr id="25" name="Text 23"/>
+          <p:cNvPr id="29" name="Text 27"/>
           <p:cNvSpPr/>
           <p:nvPr/>
         </p:nvSpPr>
@@ -1653,14 +1779,14 @@
       </p:sp>
       <p:sp>
         <p:nvSpPr>
-          <p:cNvPr id="26" name="Text 24"/>
-          <p:cNvSpPr/>
-          <p:nvPr/>
-        </p:nvSpPr>
-        <p:spPr>
-          <a:xfrm>
-            <a:off x="3264408" y="1527048"/>
-            <a:ext cx="2560320" cy="2743200"/>
+          <p:cNvPr id="30" name="Text 28"/>
+          <p:cNvSpPr/>
+          <p:nvPr/>
+        </p:nvSpPr>
+        <p:spPr>
+          <a:xfrm>
+            <a:off x="3264408" y="1508760"/>
+            <a:ext cx="2560320" cy="2487168"/>
           </a:xfrm>
           <a:prstGeom prst="rect">
             <a:avLst/>
@@ -1674,12 +1800,12 @@
           <a:p>
             <a:pPr indent="0" marL="0">
               <a:spcAft>
-                <a:spcPts val="600"/>
+                <a:spcPts val="500"/>
               </a:spcAft>
               <a:buNone/>
             </a:pPr>
             <a:r>
-              <a:rPr lang="en-US" sz="1250" dirty="0">
+              <a:rPr lang="en-US" sz="1200" dirty="0">
                 <a:solidFill>
                   <a:srgbClr val="374151"/>
                 </a:solidFill>
@@ -1689,17 +1815,17 @@
               </a:rPr>
               <a:t>🔍  Transparency — peer benchmarking</a:t>
             </a:r>
-            <a:endParaRPr lang="en-US" sz="1250" dirty="0"/>
+            <a:endParaRPr lang="en-US" sz="1200" dirty="0"/>
           </a:p>
           <a:p>
             <a:pPr indent="0" marL="0">
               <a:spcAft>
-                <a:spcPts val="600"/>
+                <a:spcPts val="500"/>
               </a:spcAft>
               <a:buNone/>
             </a:pPr>
             <a:r>
-              <a:rPr lang="en-US" sz="1250" dirty="0">
+              <a:rPr lang="en-US" sz="1200" dirty="0">
                 <a:solidFill>
                   <a:srgbClr val="374151"/>
                 </a:solidFill>
@@ -1709,17 +1835,17 @@
               </a:rPr>
               <a:t>📊  Labor Market — job demand signals</a:t>
             </a:r>
-            <a:endParaRPr lang="en-US" sz="1250" dirty="0"/>
+            <a:endParaRPr lang="en-US" sz="1200" dirty="0"/>
           </a:p>
           <a:p>
             <a:pPr indent="0" marL="0">
               <a:spcAft>
-                <a:spcPts val="600"/>
+                <a:spcPts val="500"/>
               </a:spcAft>
               <a:buNone/>
             </a:pPr>
             <a:r>
-              <a:rPr lang="en-US" sz="1250" dirty="0">
+              <a:rPr lang="en-US" sz="1200" dirty="0">
                 <a:solidFill>
                   <a:srgbClr val="374151"/>
                 </a:solidFill>
@@ -1727,19 +1853,19 @@
                 <a:ea typeface="Calibri" pitchFamily="34" charset="-122"/>
                 <a:cs typeface="Calibri" pitchFamily="34" charset="-120"/>
               </a:rPr>
-              <a:t>🎯  Competencies — ACM/credential alignment</a:t>
-            </a:r>
-            <a:endParaRPr lang="en-US" sz="1250" dirty="0"/>
+              <a:t>🎯  Competencies — live CTDL alignment</a:t>
+            </a:r>
+            <a:endParaRPr lang="en-US" sz="1200" dirty="0"/>
           </a:p>
           <a:p>
             <a:pPr indent="0" marL="0">
               <a:spcAft>
-                <a:spcPts val="600"/>
+                <a:spcPts val="500"/>
               </a:spcAft>
               <a:buNone/>
             </a:pPr>
             <a:r>
-              <a:rPr lang="en-US" sz="1250" dirty="0">
+              <a:rPr lang="en-US" sz="1200" dirty="0">
                 <a:solidFill>
                   <a:srgbClr val="374151"/>
                 </a:solidFill>
@@ -1749,17 +1875,17 @@
               </a:rPr>
               <a:t>🏛️  University Strategy — institutional goals</a:t>
             </a:r>
-            <a:endParaRPr lang="en-US" sz="1250" dirty="0"/>
+            <a:endParaRPr lang="en-US" sz="1200" dirty="0"/>
           </a:p>
           <a:p>
             <a:pPr indent="0" marL="0">
               <a:spcAft>
-                <a:spcPts val="600"/>
+                <a:spcPts val="500"/>
               </a:spcAft>
               <a:buNone/>
             </a:pPr>
             <a:r>
-              <a:rPr lang="en-US" sz="1250" dirty="0">
+              <a:rPr lang="en-US" sz="1200" dirty="0">
                 <a:solidFill>
                   <a:srgbClr val="374151"/>
                 </a:solidFill>
@@ -1767,19 +1893,19 @@
                 <a:ea typeface="Calibri" pitchFamily="34" charset="-122"/>
                 <a:cs typeface="Calibri" pitchFamily="34" charset="-120"/>
               </a:rPr>
-              <a:t>✅  Assessment — AI-proof evaluation design</a:t>
-            </a:r>
-            <a:endParaRPr lang="en-US" sz="1250" dirty="0"/>
+              <a:t>✅  Assessment — AI-proof evaluation</a:t>
+            </a:r>
+            <a:endParaRPr lang="en-US" sz="1200" dirty="0"/>
           </a:p>
           <a:p>
             <a:pPr indent="0" marL="0">
               <a:spcAft>
-                <a:spcPts val="600"/>
+                <a:spcPts val="500"/>
               </a:spcAft>
               <a:buNone/>
             </a:pPr>
             <a:r>
-              <a:rPr lang="en-US" sz="1250" dirty="0">
+              <a:rPr lang="en-US" sz="1200" dirty="0">
                 <a:solidFill>
                   <a:srgbClr val="374151"/>
                 </a:solidFill>
@@ -1789,13 +1915,94 @@
               </a:rPr>
               <a:t>📋  Policy — compliance check</a:t>
             </a:r>
-            <a:endParaRPr lang="en-US" sz="1250" dirty="0"/>
-          </a:p>
-        </p:txBody>
-      </p:sp>
-      <p:sp>
-        <p:nvSpPr>
-          <p:cNvPr id="27" name="Shape 25"/>
+            <a:endParaRPr lang="en-US" sz="1200" dirty="0"/>
+          </a:p>
+        </p:txBody>
+      </p:sp>
+      <p:sp>
+        <p:nvSpPr>
+          <p:cNvPr id="31" name="Shape 29"/>
+          <p:cNvSpPr/>
+          <p:nvPr/>
+        </p:nvSpPr>
+        <p:spPr>
+          <a:xfrm>
+            <a:off x="3264408" y="3886200"/>
+            <a:ext cx="2560320" cy="384048"/>
+          </a:xfrm>
+          <a:prstGeom prst="rect">
+            <a:avLst/>
+          </a:prstGeom>
+          <a:solidFill>
+            <a:srgbClr val="EFF6FF"/>
+          </a:solidFill>
+          <a:ln w="12700">
+            <a:solidFill>
+              <a:srgbClr val="BFDBFE"/>
+            </a:solidFill>
+            <a:prstDash val="solid"/>
+          </a:ln>
+        </p:spPr>
+      </p:sp>
+      <p:sp>
+        <p:nvSpPr>
+          <p:cNvPr id="32" name="Text 30"/>
+          <p:cNvSpPr/>
+          <p:nvPr/>
+        </p:nvSpPr>
+        <p:spPr>
+          <a:xfrm>
+            <a:off x="3310128" y="3904488"/>
+            <a:ext cx="2468880" cy="347472"/>
+          </a:xfrm>
+          <a:prstGeom prst="rect">
+            <a:avLst/>
+          </a:prstGeom>
+          <a:noFill/>
+          <a:ln/>
+        </p:spPr>
+        <p:txBody>
+          <a:bodyPr wrap="square" lIns="0" tIns="0" rIns="0" bIns="0" rtlCol="0" anchor="ctr"/>
+          <a:lstStyle/>
+          <a:p>
+            <a:pPr indent="0" marL="0">
+              <a:buNone/>
+            </a:pPr>
+            <a:r>
+              <a:rPr lang="en-US" sz="950" dirty="0">
+                <a:solidFill>
+                  <a:srgbClr val="1E40AF"/>
+                </a:solidFill>
+                <a:latin typeface="Calibri" pitchFamily="34" charset="0"/>
+                <a:ea typeface="Calibri" pitchFamily="34" charset="-122"/>
+                <a:cs typeface="Calibri" pitchFamily="34" charset="-120"/>
+              </a:rPr>
+              <a:t>📡  Live data: Credential Registry (CTDL)</a:t>
+            </a:r>
+            <a:endParaRPr lang="en-US" sz="950" dirty="0"/>
+          </a:p>
+          <a:p>
+            <a:pPr indent="0" marL="0">
+              <a:buNone/>
+            </a:pPr>
+            <a:r>
+              <a:rPr lang="en-US" sz="950" dirty="0">
+                <a:solidFill>
+                  <a:srgbClr val="1E40AF"/>
+                </a:solidFill>
+                <a:latin typeface="Calibri" pitchFamily="34" charset="0"/>
+                <a:ea typeface="Calibri" pitchFamily="34" charset="-122"/>
+                <a:cs typeface="Calibri" pitchFamily="34" charset="-120"/>
+              </a:rPr>
+              <a:t>Fetched at startup · citations link to source</a:t>
+            </a:r>
+            <a:endParaRPr lang="en-US" sz="950" dirty="0"/>
+          </a:p>
+        </p:txBody>
+      </p:sp>
+      <p:sp>
+        <p:nvSpPr>
+          <p:cNvPr id="33" name="Shape 31"/>
           <p:cNvSpPr/>
           <p:nvPr/>
         </p:nvSpPr>
@@ -1827,7 +2034,7 @@
       </p:sp>
       <p:sp>
         <p:nvSpPr>
-          <p:cNvPr id="28" name="Shape 26"/>
+          <p:cNvPr id="34" name="Shape 32"/>
           <p:cNvSpPr/>
           <p:nvPr/>
         </p:nvSpPr>
@@ -1852,7 +2059,7 @@
       </p:sp>
       <p:sp>
         <p:nvSpPr>
-          <p:cNvPr id="29" name="Text 27"/>
+          <p:cNvPr id="35" name="Text 33"/>
           <p:cNvSpPr/>
           <p:nvPr/>
         </p:nvSpPr>
@@ -1891,14 +2098,14 @@
       </p:sp>
       <p:sp>
         <p:nvSpPr>
-          <p:cNvPr id="30" name="Shape 28"/>
-          <p:cNvSpPr/>
-          <p:nvPr/>
-        </p:nvSpPr>
-        <p:spPr>
-          <a:xfrm>
-            <a:off x="6327648" y="1527048"/>
-            <a:ext cx="2560320" cy="457200"/>
+          <p:cNvPr id="36" name="Shape 34"/>
+          <p:cNvSpPr/>
+          <p:nvPr/>
+        </p:nvSpPr>
+        <p:spPr>
+          <a:xfrm>
+            <a:off x="6327648" y="1490472"/>
+            <a:ext cx="2560320" cy="402336"/>
           </a:xfrm>
           <a:prstGeom prst="rect">
             <a:avLst/>
@@ -1916,13 +2123,13 @@
       </p:sp>
       <p:sp>
         <p:nvSpPr>
-          <p:cNvPr id="31" name="Shape 29"/>
-          <p:cNvSpPr/>
-          <p:nvPr/>
-        </p:nvSpPr>
-        <p:spPr>
-          <a:xfrm>
-            <a:off x="6373368" y="1618488"/>
+          <p:cNvPr id="37" name="Shape 35"/>
+          <p:cNvSpPr/>
+          <p:nvPr/>
+        </p:nvSpPr>
+        <p:spPr>
+          <a:xfrm>
+            <a:off x="6373368" y="1581912"/>
             <a:ext cx="420624" cy="201168"/>
           </a:xfrm>
           <a:prstGeom prst="rect">
@@ -1941,13 +2148,13 @@
       </p:sp>
       <p:sp>
         <p:nvSpPr>
-          <p:cNvPr id="32" name="Text 30"/>
-          <p:cNvSpPr/>
-          <p:nvPr/>
-        </p:nvSpPr>
-        <p:spPr>
-          <a:xfrm>
-            <a:off x="6373368" y="1618488"/>
+          <p:cNvPr id="38" name="Text 36"/>
+          <p:cNvSpPr/>
+          <p:nvPr/>
+        </p:nvSpPr>
+        <p:spPr>
+          <a:xfrm>
+            <a:off x="6373368" y="1581912"/>
             <a:ext cx="420624" cy="201168"/>
           </a:xfrm>
           <a:prstGeom prst="rect">
@@ -1980,14 +2187,14 @@
       </p:sp>
       <p:sp>
         <p:nvSpPr>
-          <p:cNvPr id="33" name="Text 31"/>
-          <p:cNvSpPr/>
-          <p:nvPr/>
-        </p:nvSpPr>
-        <p:spPr>
-          <a:xfrm>
-            <a:off x="6858000" y="1581912"/>
-            <a:ext cx="1965960" cy="347472"/>
+          <p:cNvPr id="39" name="Text 37"/>
+          <p:cNvSpPr/>
+          <p:nvPr/>
+        </p:nvSpPr>
+        <p:spPr>
+          <a:xfrm>
+            <a:off x="6858000" y="1536192"/>
+            <a:ext cx="1947672" cy="320040"/>
           </a:xfrm>
           <a:prstGeom prst="rect">
             <a:avLst/>
@@ -2003,7 +2210,7 @@
               <a:buNone/>
             </a:pPr>
             <a:r>
-              <a:rPr lang="en-US" sz="1150" dirty="0">
+              <a:rPr lang="en-US" sz="1100" dirty="0">
                 <a:solidFill>
                   <a:srgbClr val="1A202C"/>
                 </a:solidFill>
@@ -2013,20 +2220,20 @@
               </a:rPr>
               <a:t>Add Graph Algorithms module</a:t>
             </a:r>
-            <a:endParaRPr lang="en-US" sz="1150" dirty="0"/>
-          </a:p>
-        </p:txBody>
-      </p:sp>
-      <p:sp>
-        <p:nvSpPr>
-          <p:cNvPr id="34" name="Shape 32"/>
-          <p:cNvSpPr/>
-          <p:nvPr/>
-        </p:nvSpPr>
-        <p:spPr>
-          <a:xfrm>
-            <a:off x="6327648" y="2084832"/>
-            <a:ext cx="2560320" cy="457200"/>
+            <a:endParaRPr lang="en-US" sz="1100" dirty="0"/>
+          </a:p>
+        </p:txBody>
+      </p:sp>
+      <p:sp>
+        <p:nvSpPr>
+          <p:cNvPr id="40" name="Shape 38"/>
+          <p:cNvSpPr/>
+          <p:nvPr/>
+        </p:nvSpPr>
+        <p:spPr>
+          <a:xfrm>
+            <a:off x="6327648" y="1965960"/>
+            <a:ext cx="2560320" cy="402336"/>
           </a:xfrm>
           <a:prstGeom prst="rect">
             <a:avLst/>
@@ -2044,13 +2251,13 @@
       </p:sp>
       <p:sp>
         <p:nvSpPr>
-          <p:cNvPr id="35" name="Shape 33"/>
-          <p:cNvSpPr/>
-          <p:nvPr/>
-        </p:nvSpPr>
-        <p:spPr>
-          <a:xfrm>
-            <a:off x="6373368" y="2176272"/>
+          <p:cNvPr id="41" name="Shape 39"/>
+          <p:cNvSpPr/>
+          <p:nvPr/>
+        </p:nvSpPr>
+        <p:spPr>
+          <a:xfrm>
+            <a:off x="6373368" y="2057400"/>
             <a:ext cx="420624" cy="201168"/>
           </a:xfrm>
           <a:prstGeom prst="rect">
@@ -2069,13 +2276,13 @@
       </p:sp>
       <p:sp>
         <p:nvSpPr>
-          <p:cNvPr id="36" name="Text 34"/>
-          <p:cNvSpPr/>
-          <p:nvPr/>
-        </p:nvSpPr>
-        <p:spPr>
-          <a:xfrm>
-            <a:off x="6373368" y="2176272"/>
+          <p:cNvPr id="42" name="Text 40"/>
+          <p:cNvSpPr/>
+          <p:nvPr/>
+        </p:nvSpPr>
+        <p:spPr>
+          <a:xfrm>
+            <a:off x="6373368" y="2057400"/>
             <a:ext cx="420624" cy="201168"/>
           </a:xfrm>
           <a:prstGeom prst="rect">
@@ -2108,14 +2315,14 @@
       </p:sp>
       <p:sp>
         <p:nvSpPr>
-          <p:cNvPr id="37" name="Text 35"/>
-          <p:cNvSpPr/>
-          <p:nvPr/>
-        </p:nvSpPr>
-        <p:spPr>
-          <a:xfrm>
-            <a:off x="6858000" y="2139696"/>
-            <a:ext cx="1965960" cy="347472"/>
+          <p:cNvPr id="43" name="Text 41"/>
+          <p:cNvSpPr/>
+          <p:nvPr/>
+        </p:nvSpPr>
+        <p:spPr>
+          <a:xfrm>
+            <a:off x="6858000" y="2011680"/>
+            <a:ext cx="1947672" cy="320040"/>
           </a:xfrm>
           <a:prstGeom prst="rect">
             <a:avLst/>
@@ -2131,7 +2338,7 @@
               <a:buNone/>
             </a:pPr>
             <a:r>
-              <a:rPr lang="en-US" sz="1150" dirty="0">
+              <a:rPr lang="en-US" sz="1100" dirty="0">
                 <a:solidFill>
                   <a:srgbClr val="1A202C"/>
                 </a:solidFill>
@@ -2141,20 +2348,20 @@
               </a:rPr>
               <a:t>Add AI use policy</a:t>
             </a:r>
-            <a:endParaRPr lang="en-US" sz="1150" dirty="0"/>
-          </a:p>
-        </p:txBody>
-      </p:sp>
-      <p:sp>
-        <p:nvSpPr>
-          <p:cNvPr id="38" name="Shape 36"/>
-          <p:cNvSpPr/>
-          <p:nvPr/>
-        </p:nvSpPr>
-        <p:spPr>
-          <a:xfrm>
-            <a:off x="6327648" y="2642616"/>
-            <a:ext cx="2560320" cy="457200"/>
+            <a:endParaRPr lang="en-US" sz="1100" dirty="0"/>
+          </a:p>
+        </p:txBody>
+      </p:sp>
+      <p:sp>
+        <p:nvSpPr>
+          <p:cNvPr id="44" name="Shape 42"/>
+          <p:cNvSpPr/>
+          <p:nvPr/>
+        </p:nvSpPr>
+        <p:spPr>
+          <a:xfrm>
+            <a:off x="6327648" y="2441448"/>
+            <a:ext cx="2560320" cy="402336"/>
           </a:xfrm>
           <a:prstGeom prst="rect">
             <a:avLst/>
@@ -2172,13 +2379,13 @@
       </p:sp>
       <p:sp>
         <p:nvSpPr>
-          <p:cNvPr id="39" name="Shape 37"/>
-          <p:cNvSpPr/>
-          <p:nvPr/>
-        </p:nvSpPr>
-        <p:spPr>
-          <a:xfrm>
-            <a:off x="6373368" y="2734056"/>
+          <p:cNvPr id="45" name="Shape 43"/>
+          <p:cNvSpPr/>
+          <p:nvPr/>
+        </p:nvSpPr>
+        <p:spPr>
+          <a:xfrm>
+            <a:off x="6373368" y="2532888"/>
             <a:ext cx="420624" cy="201168"/>
           </a:xfrm>
           <a:prstGeom prst="rect">
@@ -2197,13 +2404,13 @@
       </p:sp>
       <p:sp>
         <p:nvSpPr>
-          <p:cNvPr id="40" name="Text 38"/>
-          <p:cNvSpPr/>
-          <p:nvPr/>
-        </p:nvSpPr>
-        <p:spPr>
-          <a:xfrm>
-            <a:off x="6373368" y="2734056"/>
+          <p:cNvPr id="46" name="Text 44"/>
+          <p:cNvSpPr/>
+          <p:nvPr/>
+        </p:nvSpPr>
+        <p:spPr>
+          <a:xfrm>
+            <a:off x="6373368" y="2532888"/>
             <a:ext cx="420624" cy="201168"/>
           </a:xfrm>
           <a:prstGeom prst="rect">
@@ -2236,14 +2443,14 @@
       </p:sp>
       <p:sp>
         <p:nvSpPr>
-          <p:cNvPr id="41" name="Text 39"/>
-          <p:cNvSpPr/>
-          <p:nvPr/>
-        </p:nvSpPr>
-        <p:spPr>
-          <a:xfrm>
-            <a:off x="6858000" y="2697480"/>
-            <a:ext cx="1965960" cy="347472"/>
+          <p:cNvPr id="47" name="Text 45"/>
+          <p:cNvSpPr/>
+          <p:nvPr/>
+        </p:nvSpPr>
+        <p:spPr>
+          <a:xfrm>
+            <a:off x="6858000" y="2487168"/>
+            <a:ext cx="1947672" cy="320040"/>
           </a:xfrm>
           <a:prstGeom prst="rect">
             <a:avLst/>
@@ -2259,7 +2466,7 @@
               <a:buNone/>
             </a:pPr>
             <a:r>
-              <a:rPr lang="en-US" sz="1150" dirty="0">
+              <a:rPr lang="en-US" sz="1100" dirty="0">
                 <a:solidFill>
                   <a:srgbClr val="1A202C"/>
                 </a:solidFill>
@@ -2269,20 +2476,20 @@
               </a:rPr>
               <a:t>Whiteboard coding defense</a:t>
             </a:r>
-            <a:endParaRPr lang="en-US" sz="1150" dirty="0"/>
-          </a:p>
-        </p:txBody>
-      </p:sp>
-      <p:sp>
-        <p:nvSpPr>
-          <p:cNvPr id="42" name="Shape 40"/>
-          <p:cNvSpPr/>
-          <p:nvPr/>
-        </p:nvSpPr>
-        <p:spPr>
-          <a:xfrm>
-            <a:off x="6327648" y="3200400"/>
-            <a:ext cx="2560320" cy="457200"/>
+            <a:endParaRPr lang="en-US" sz="1100" dirty="0"/>
+          </a:p>
+        </p:txBody>
+      </p:sp>
+      <p:sp>
+        <p:nvSpPr>
+          <p:cNvPr id="48" name="Shape 46"/>
+          <p:cNvSpPr/>
+          <p:nvPr/>
+        </p:nvSpPr>
+        <p:spPr>
+          <a:xfrm>
+            <a:off x="6327648" y="2916936"/>
+            <a:ext cx="2560320" cy="402336"/>
           </a:xfrm>
           <a:prstGeom prst="rect">
             <a:avLst/>
@@ -2300,13 +2507,13 @@
       </p:sp>
       <p:sp>
         <p:nvSpPr>
-          <p:cNvPr id="43" name="Shape 41"/>
-          <p:cNvSpPr/>
-          <p:nvPr/>
-        </p:nvSpPr>
-        <p:spPr>
-          <a:xfrm>
-            <a:off x="6373368" y="3291840"/>
+          <p:cNvPr id="49" name="Shape 47"/>
+          <p:cNvSpPr/>
+          <p:nvPr/>
+        </p:nvSpPr>
+        <p:spPr>
+          <a:xfrm>
+            <a:off x="6373368" y="3008376"/>
             <a:ext cx="420624" cy="201168"/>
           </a:xfrm>
           <a:prstGeom prst="rect">
@@ -2325,13 +2532,13 @@
       </p:sp>
       <p:sp>
         <p:nvSpPr>
-          <p:cNvPr id="44" name="Text 42"/>
-          <p:cNvSpPr/>
-          <p:nvPr/>
-        </p:nvSpPr>
-        <p:spPr>
-          <a:xfrm>
-            <a:off x="6373368" y="3291840"/>
+          <p:cNvPr id="50" name="Text 48"/>
+          <p:cNvSpPr/>
+          <p:nvPr/>
+        </p:nvSpPr>
+        <p:spPr>
+          <a:xfrm>
+            <a:off x="6373368" y="3008376"/>
             <a:ext cx="420624" cy="201168"/>
           </a:xfrm>
           <a:prstGeom prst="rect">
@@ -2364,14 +2571,14 @@
       </p:sp>
       <p:sp>
         <p:nvSpPr>
-          <p:cNvPr id="45" name="Text 43"/>
-          <p:cNvSpPr/>
-          <p:nvPr/>
-        </p:nvSpPr>
-        <p:spPr>
-          <a:xfrm>
-            <a:off x="6858000" y="3255264"/>
-            <a:ext cx="1965960" cy="347472"/>
+          <p:cNvPr id="51" name="Text 49"/>
+          <p:cNvSpPr/>
+          <p:nvPr/>
+        </p:nvSpPr>
+        <p:spPr>
+          <a:xfrm>
+            <a:off x="6858000" y="2962656"/>
+            <a:ext cx="1947672" cy="320040"/>
           </a:xfrm>
           <a:prstGeom prst="rect">
             <a:avLst/>
@@ -2387,7 +2594,7 @@
               <a:buNone/>
             </a:pPr>
             <a:r>
-              <a:rPr lang="en-US" sz="1150" dirty="0">
+              <a:rPr lang="en-US" sz="1100" dirty="0">
                 <a:solidFill>
                   <a:srgbClr val="1A202C"/>
                 </a:solidFill>
@@ -2397,20 +2604,20 @@
               </a:rPr>
               <a:t>Parallel algorithms unit</a:t>
             </a:r>
-            <a:endParaRPr lang="en-US" sz="1150" dirty="0"/>
-          </a:p>
-        </p:txBody>
-      </p:sp>
-      <p:sp>
-        <p:nvSpPr>
-          <p:cNvPr id="46" name="Shape 44"/>
-          <p:cNvSpPr/>
-          <p:nvPr/>
-        </p:nvSpPr>
-        <p:spPr>
-          <a:xfrm>
-            <a:off x="6327648" y="3758184"/>
-            <a:ext cx="2560320" cy="457200"/>
+            <a:endParaRPr lang="en-US" sz="1100" dirty="0"/>
+          </a:p>
+        </p:txBody>
+      </p:sp>
+      <p:sp>
+        <p:nvSpPr>
+          <p:cNvPr id="52" name="Shape 50"/>
+          <p:cNvSpPr/>
+          <p:nvPr/>
+        </p:nvSpPr>
+        <p:spPr>
+          <a:xfrm>
+            <a:off x="6327648" y="3392424"/>
+            <a:ext cx="2560320" cy="402336"/>
           </a:xfrm>
           <a:prstGeom prst="rect">
             <a:avLst/>
@@ -2428,13 +2635,13 @@
       </p:sp>
       <p:sp>
         <p:nvSpPr>
-          <p:cNvPr id="47" name="Shape 45"/>
-          <p:cNvSpPr/>
-          <p:nvPr/>
-        </p:nvSpPr>
-        <p:spPr>
-          <a:xfrm>
-            <a:off x="6373368" y="3849624"/>
+          <p:cNvPr id="53" name="Shape 51"/>
+          <p:cNvSpPr/>
+          <p:nvPr/>
+        </p:nvSpPr>
+        <p:spPr>
+          <a:xfrm>
+            <a:off x="6373368" y="3483864"/>
             <a:ext cx="420624" cy="201168"/>
           </a:xfrm>
           <a:prstGeom prst="rect">
@@ -2453,13 +2660,13 @@
       </p:sp>
       <p:sp>
         <p:nvSpPr>
-          <p:cNvPr id="48" name="Text 46"/>
-          <p:cNvSpPr/>
-          <p:nvPr/>
-        </p:nvSpPr>
-        <p:spPr>
-          <a:xfrm>
-            <a:off x="6373368" y="3849624"/>
+          <p:cNvPr id="54" name="Text 52"/>
+          <p:cNvSpPr/>
+          <p:nvPr/>
+        </p:nvSpPr>
+        <p:spPr>
+          <a:xfrm>
+            <a:off x="6373368" y="3483864"/>
             <a:ext cx="420624" cy="201168"/>
           </a:xfrm>
           <a:prstGeom prst="rect">
@@ -2492,14 +2699,14 @@
       </p:sp>
       <p:sp>
         <p:nvSpPr>
-          <p:cNvPr id="49" name="Text 47"/>
-          <p:cNvSpPr/>
-          <p:nvPr/>
-        </p:nvSpPr>
-        <p:spPr>
-          <a:xfrm>
-            <a:off x="6858000" y="3813048"/>
-            <a:ext cx="1965960" cy="347472"/>
+          <p:cNvPr id="55" name="Text 53"/>
+          <p:cNvSpPr/>
+          <p:nvPr/>
+        </p:nvSpPr>
+        <p:spPr>
+          <a:xfrm>
+            <a:off x="6858000" y="3438144"/>
+            <a:ext cx="1947672" cy="320040"/>
           </a:xfrm>
           <a:prstGeom prst="rect">
             <a:avLst/>
@@ -2515,7 +2722,7 @@
               <a:buNone/>
             </a:pPr>
             <a:r>
-              <a:rPr lang="en-US" sz="1150" dirty="0">
+              <a:rPr lang="en-US" sz="1100" dirty="0">
                 <a:solidFill>
                   <a:srgbClr val="1A202C"/>
                 </a:solidFill>
@@ -2523,15 +2730,96 @@
                 <a:ea typeface="Calibri" pitchFamily="34" charset="-122"/>
                 <a:cs typeface="Calibri" pitchFamily="34" charset="-120"/>
               </a:rPr>
-              <a:t>Competitive programming project</a:t>
-            </a:r>
-            <a:endParaRPr lang="en-US" sz="1150" dirty="0"/>
-          </a:p>
-        </p:txBody>
-      </p:sp>
-      <p:sp>
-        <p:nvSpPr>
-          <p:cNvPr id="50" name="Shape 48"/>
+              <a:t>Competitive programming</a:t>
+            </a:r>
+            <a:endParaRPr lang="en-US" sz="1100" dirty="0"/>
+          </a:p>
+        </p:txBody>
+      </p:sp>
+      <p:sp>
+        <p:nvSpPr>
+          <p:cNvPr id="56" name="Shape 54"/>
+          <p:cNvSpPr/>
+          <p:nvPr/>
+        </p:nvSpPr>
+        <p:spPr>
+          <a:xfrm>
+            <a:off x="6327648" y="3886200"/>
+            <a:ext cx="2560320" cy="384048"/>
+          </a:xfrm>
+          <a:prstGeom prst="rect">
+            <a:avLst/>
+          </a:prstGeom>
+          <a:solidFill>
+            <a:srgbClr val="F0FDF4"/>
+          </a:solidFill>
+          <a:ln w="12700">
+            <a:solidFill>
+              <a:srgbClr val="BBF7D0"/>
+            </a:solidFill>
+            <a:prstDash val="solid"/>
+          </a:ln>
+        </p:spPr>
+      </p:sp>
+      <p:sp>
+        <p:nvSpPr>
+          <p:cNvPr id="57" name="Text 55"/>
+          <p:cNvSpPr/>
+          <p:nvPr/>
+        </p:nvSpPr>
+        <p:spPr>
+          <a:xfrm>
+            <a:off x="6373368" y="3904488"/>
+            <a:ext cx="2468880" cy="347472"/>
+          </a:xfrm>
+          <a:prstGeom prst="rect">
+            <a:avLst/>
+          </a:prstGeom>
+          <a:noFill/>
+          <a:ln/>
+        </p:spPr>
+        <p:txBody>
+          <a:bodyPr wrap="square" lIns="0" tIns="0" rIns="0" bIns="0" rtlCol="0" anchor="ctr"/>
+          <a:lstStyle/>
+          <a:p>
+            <a:pPr indent="0" marL="0">
+              <a:buNone/>
+            </a:pPr>
+            <a:r>
+              <a:rPr lang="en-US" sz="950" dirty="0">
+                <a:solidFill>
+                  <a:srgbClr val="14532D"/>
+                </a:solidFill>
+                <a:latin typeface="Calibri" pitchFamily="34" charset="0"/>
+                <a:ea typeface="Calibri" pitchFamily="34" charset="-122"/>
+                <a:cs typeface="Calibri" pitchFamily="34" charset="-120"/>
+              </a:rPr>
+              <a:t>⬇  Select improvements → export to .docx</a:t>
+            </a:r>
+            <a:endParaRPr lang="en-US" sz="950" dirty="0"/>
+          </a:p>
+          <a:p>
+            <a:pPr indent="0" marL="0">
+              <a:buNone/>
+            </a:pPr>
+            <a:r>
+              <a:rPr lang="en-US" sz="950" dirty="0">
+                <a:solidFill>
+                  <a:srgbClr val="14532D"/>
+                </a:solidFill>
+                <a:latin typeface="Calibri" pitchFamily="34" charset="0"/>
+                <a:ea typeface="Calibri" pitchFamily="34" charset="-122"/>
+                <a:cs typeface="Calibri" pitchFamily="34" charset="-120"/>
+              </a:rPr>
+              <a:t>Faculty edits in Word or Google Docs</a:t>
+            </a:r>
+            <a:endParaRPr lang="en-US" sz="950" dirty="0"/>
+          </a:p>
+        </p:txBody>
+      </p:sp>
+      <p:sp>
+        <p:nvSpPr>
+          <p:cNvPr id="58" name="Shape 56"/>
           <p:cNvSpPr/>
           <p:nvPr/>
         </p:nvSpPr>
@@ -2556,7 +2844,7 @@
       </p:sp>
       <p:sp>
         <p:nvSpPr>
-          <p:cNvPr id="51" name="Text 49"/>
+          <p:cNvPr id="59" name="Text 57"/>
           <p:cNvSpPr/>
           <p:nvPr/>
         </p:nvSpPr>
@@ -2587,7 +2875,7 @@
                 <a:ea typeface="Calibri" pitchFamily="34" charset="-122"/>
                 <a:cs typeface="Calibri" pitchFamily="34" charset="-120"/>
               </a:rPr>
-              <a:t>Pilot: CS Algorithms course  │  Stack: FastAPI + React + Claude API  │  Build-a-thon 2026</a:t>
+              <a:t>Pilot: CS Algorithms  │  Data: Credential Registry (CTDL)  │  Stack: FastAPI + React  │  Wharton/Gates Build-a-thon 2026</a:t>
             </a:r>
             <a:endParaRPr lang="en-US" sz="1100" dirty="0"/>
           </a:p>

</xml_diff>

<commit_message>
Update demo slide: reflect live Claude Haiku integration
Add Claude Haiku badge, update step 2 and footer stack.

Co-Authored-By: Claude Sonnet 4.6 <noreply@anthropic.com>
</commit_message>
<xml_diff>
--- a/Faculty Co-Design Demo Slide.pptx
+++ b/Faculty Co-Design Demo Slide.pptx
@@ -1297,7 +1297,7 @@
                 <a:ea typeface="Calibri" pitchFamily="34" charset="-122"/>
                 <a:cs typeface="Calibri" pitchFamily="34" charset="-120"/>
               </a:rPr>
-              <a:t>6 AI agents analyze in parallel</a:t>
+              <a:t>6 Claude agents analyze in parallel</a:t>
             </a:r>
             <a:endParaRPr lang="en-US" sz="1150" dirty="0"/>
           </a:p>
@@ -1786,7 +1786,7 @@
         <p:spPr>
           <a:xfrm>
             <a:off x="3264408" y="1508760"/>
-            <a:ext cx="2560320" cy="2487168"/>
+            <a:ext cx="2560320" cy="2212848"/>
           </a:xfrm>
           <a:prstGeom prst="rect">
             <a:avLst/>
@@ -1922,6 +1922,87 @@
       <p:sp>
         <p:nvSpPr>
           <p:cNvPr id="31" name="Shape 29"/>
+          <p:cNvSpPr/>
+          <p:nvPr/>
+        </p:nvSpPr>
+        <p:spPr>
+          <a:xfrm>
+            <a:off x="3264408" y="3502152"/>
+            <a:ext cx="2560320" cy="384048"/>
+          </a:xfrm>
+          <a:prstGeom prst="rect">
+            <a:avLst/>
+          </a:prstGeom>
+          <a:solidFill>
+            <a:srgbClr val="EDE9FE"/>
+          </a:solidFill>
+          <a:ln w="12700">
+            <a:solidFill>
+              <a:srgbClr val="C4B5FD"/>
+            </a:solidFill>
+            <a:prstDash val="solid"/>
+          </a:ln>
+        </p:spPr>
+      </p:sp>
+      <p:sp>
+        <p:nvSpPr>
+          <p:cNvPr id="32" name="Text 30"/>
+          <p:cNvSpPr/>
+          <p:nvPr/>
+        </p:nvSpPr>
+        <p:spPr>
+          <a:xfrm>
+            <a:off x="3310128" y="3520440"/>
+            <a:ext cx="2468880" cy="347472"/>
+          </a:xfrm>
+          <a:prstGeom prst="rect">
+            <a:avLst/>
+          </a:prstGeom>
+          <a:noFill/>
+          <a:ln/>
+        </p:spPr>
+        <p:txBody>
+          <a:bodyPr wrap="square" lIns="0" tIns="0" rIns="0" bIns="0" rtlCol="0" anchor="ctr"/>
+          <a:lstStyle/>
+          <a:p>
+            <a:pPr indent="0" marL="0">
+              <a:buNone/>
+            </a:pPr>
+            <a:r>
+              <a:rPr lang="en-US" sz="950" dirty="0">
+                <a:solidFill>
+                  <a:srgbClr val="5B21B6"/>
+                </a:solidFill>
+                <a:latin typeface="Calibri" pitchFamily="34" charset="0"/>
+                <a:ea typeface="Calibri" pitchFamily="34" charset="-122"/>
+                <a:cs typeface="Calibri" pitchFamily="34" charset="-120"/>
+              </a:rPr>
+              <a:t>🤖  Powered by Claude Haiku</a:t>
+            </a:r>
+            <a:endParaRPr lang="en-US" sz="950" dirty="0"/>
+          </a:p>
+          <a:p>
+            <a:pPr indent="0" marL="0">
+              <a:buNone/>
+            </a:pPr>
+            <a:r>
+              <a:rPr lang="en-US" sz="950" dirty="0">
+                <a:solidFill>
+                  <a:srgbClr val="5B21B6"/>
+                </a:solidFill>
+                <a:latin typeface="Calibri" pitchFamily="34" charset="0"/>
+                <a:ea typeface="Calibri" pitchFamily="34" charset="-122"/>
+                <a:cs typeface="Calibri" pitchFamily="34" charset="-120"/>
+              </a:rPr>
+              <a:t>All 6 agents · graceful keyword fallback</a:t>
+            </a:r>
+            <a:endParaRPr lang="en-US" sz="950" dirty="0"/>
+          </a:p>
+        </p:txBody>
+      </p:sp>
+      <p:sp>
+        <p:nvSpPr>
+          <p:cNvPr id="33" name="Shape 31"/>
           <p:cNvSpPr/>
           <p:nvPr/>
         </p:nvSpPr>
@@ -1946,7 +2027,7 @@
       </p:sp>
       <p:sp>
         <p:nvSpPr>
-          <p:cNvPr id="32" name="Text 30"/>
+          <p:cNvPr id="34" name="Text 32"/>
           <p:cNvSpPr/>
           <p:nvPr/>
         </p:nvSpPr>
@@ -2002,7 +2083,7 @@
       </p:sp>
       <p:sp>
         <p:nvSpPr>
-          <p:cNvPr id="33" name="Shape 31"/>
+          <p:cNvPr id="35" name="Shape 33"/>
           <p:cNvSpPr/>
           <p:nvPr/>
         </p:nvSpPr>
@@ -2034,7 +2115,7 @@
       </p:sp>
       <p:sp>
         <p:nvSpPr>
-          <p:cNvPr id="34" name="Shape 32"/>
+          <p:cNvPr id="36" name="Shape 34"/>
           <p:cNvSpPr/>
           <p:nvPr/>
         </p:nvSpPr>
@@ -2059,7 +2140,7 @@
       </p:sp>
       <p:sp>
         <p:nvSpPr>
-          <p:cNvPr id="35" name="Text 33"/>
+          <p:cNvPr id="37" name="Text 35"/>
           <p:cNvSpPr/>
           <p:nvPr/>
         </p:nvSpPr>
@@ -2098,7 +2179,7 @@
       </p:sp>
       <p:sp>
         <p:nvSpPr>
-          <p:cNvPr id="36" name="Shape 34"/>
+          <p:cNvPr id="38" name="Shape 36"/>
           <p:cNvSpPr/>
           <p:nvPr/>
         </p:nvSpPr>
@@ -2123,7 +2204,7 @@
       </p:sp>
       <p:sp>
         <p:nvSpPr>
-          <p:cNvPr id="37" name="Shape 35"/>
+          <p:cNvPr id="39" name="Shape 37"/>
           <p:cNvSpPr/>
           <p:nvPr/>
         </p:nvSpPr>
@@ -2148,7 +2229,7 @@
       </p:sp>
       <p:sp>
         <p:nvSpPr>
-          <p:cNvPr id="38" name="Text 36"/>
+          <p:cNvPr id="40" name="Text 38"/>
           <p:cNvSpPr/>
           <p:nvPr/>
         </p:nvSpPr>
@@ -2187,7 +2268,7 @@
       </p:sp>
       <p:sp>
         <p:nvSpPr>
-          <p:cNvPr id="39" name="Text 37"/>
+          <p:cNvPr id="41" name="Text 39"/>
           <p:cNvSpPr/>
           <p:nvPr/>
         </p:nvSpPr>
@@ -2226,7 +2307,7 @@
       </p:sp>
       <p:sp>
         <p:nvSpPr>
-          <p:cNvPr id="40" name="Shape 38"/>
+          <p:cNvPr id="42" name="Shape 40"/>
           <p:cNvSpPr/>
           <p:nvPr/>
         </p:nvSpPr>
@@ -2251,7 +2332,7 @@
       </p:sp>
       <p:sp>
         <p:nvSpPr>
-          <p:cNvPr id="41" name="Shape 39"/>
+          <p:cNvPr id="43" name="Shape 41"/>
           <p:cNvSpPr/>
           <p:nvPr/>
         </p:nvSpPr>
@@ -2276,7 +2357,7 @@
       </p:sp>
       <p:sp>
         <p:nvSpPr>
-          <p:cNvPr id="42" name="Text 40"/>
+          <p:cNvPr id="44" name="Text 42"/>
           <p:cNvSpPr/>
           <p:nvPr/>
         </p:nvSpPr>
@@ -2315,7 +2396,7 @@
       </p:sp>
       <p:sp>
         <p:nvSpPr>
-          <p:cNvPr id="43" name="Text 41"/>
+          <p:cNvPr id="45" name="Text 43"/>
           <p:cNvSpPr/>
           <p:nvPr/>
         </p:nvSpPr>
@@ -2354,7 +2435,7 @@
       </p:sp>
       <p:sp>
         <p:nvSpPr>
-          <p:cNvPr id="44" name="Shape 42"/>
+          <p:cNvPr id="46" name="Shape 44"/>
           <p:cNvSpPr/>
           <p:nvPr/>
         </p:nvSpPr>
@@ -2379,7 +2460,7 @@
       </p:sp>
       <p:sp>
         <p:nvSpPr>
-          <p:cNvPr id="45" name="Shape 43"/>
+          <p:cNvPr id="47" name="Shape 45"/>
           <p:cNvSpPr/>
           <p:nvPr/>
         </p:nvSpPr>
@@ -2404,7 +2485,7 @@
       </p:sp>
       <p:sp>
         <p:nvSpPr>
-          <p:cNvPr id="46" name="Text 44"/>
+          <p:cNvPr id="48" name="Text 46"/>
           <p:cNvSpPr/>
           <p:nvPr/>
         </p:nvSpPr>
@@ -2443,7 +2524,7 @@
       </p:sp>
       <p:sp>
         <p:nvSpPr>
-          <p:cNvPr id="47" name="Text 45"/>
+          <p:cNvPr id="49" name="Text 47"/>
           <p:cNvSpPr/>
           <p:nvPr/>
         </p:nvSpPr>
@@ -2482,7 +2563,7 @@
       </p:sp>
       <p:sp>
         <p:nvSpPr>
-          <p:cNvPr id="48" name="Shape 46"/>
+          <p:cNvPr id="50" name="Shape 48"/>
           <p:cNvSpPr/>
           <p:nvPr/>
         </p:nvSpPr>
@@ -2507,7 +2588,7 @@
       </p:sp>
       <p:sp>
         <p:nvSpPr>
-          <p:cNvPr id="49" name="Shape 47"/>
+          <p:cNvPr id="51" name="Shape 49"/>
           <p:cNvSpPr/>
           <p:nvPr/>
         </p:nvSpPr>
@@ -2532,7 +2613,7 @@
       </p:sp>
       <p:sp>
         <p:nvSpPr>
-          <p:cNvPr id="50" name="Text 48"/>
+          <p:cNvPr id="52" name="Text 50"/>
           <p:cNvSpPr/>
           <p:nvPr/>
         </p:nvSpPr>
@@ -2571,7 +2652,7 @@
       </p:sp>
       <p:sp>
         <p:nvSpPr>
-          <p:cNvPr id="51" name="Text 49"/>
+          <p:cNvPr id="53" name="Text 51"/>
           <p:cNvSpPr/>
           <p:nvPr/>
         </p:nvSpPr>
@@ -2610,7 +2691,7 @@
       </p:sp>
       <p:sp>
         <p:nvSpPr>
-          <p:cNvPr id="52" name="Shape 50"/>
+          <p:cNvPr id="54" name="Shape 52"/>
           <p:cNvSpPr/>
           <p:nvPr/>
         </p:nvSpPr>
@@ -2635,7 +2716,7 @@
       </p:sp>
       <p:sp>
         <p:nvSpPr>
-          <p:cNvPr id="53" name="Shape 51"/>
+          <p:cNvPr id="55" name="Shape 53"/>
           <p:cNvSpPr/>
           <p:nvPr/>
         </p:nvSpPr>
@@ -2660,7 +2741,7 @@
       </p:sp>
       <p:sp>
         <p:nvSpPr>
-          <p:cNvPr id="54" name="Text 52"/>
+          <p:cNvPr id="56" name="Text 54"/>
           <p:cNvSpPr/>
           <p:nvPr/>
         </p:nvSpPr>
@@ -2699,7 +2780,7 @@
       </p:sp>
       <p:sp>
         <p:nvSpPr>
-          <p:cNvPr id="55" name="Text 53"/>
+          <p:cNvPr id="57" name="Text 55"/>
           <p:cNvSpPr/>
           <p:nvPr/>
         </p:nvSpPr>
@@ -2738,7 +2819,7 @@
       </p:sp>
       <p:sp>
         <p:nvSpPr>
-          <p:cNvPr id="56" name="Shape 54"/>
+          <p:cNvPr id="58" name="Shape 56"/>
           <p:cNvSpPr/>
           <p:nvPr/>
         </p:nvSpPr>
@@ -2763,7 +2844,7 @@
       </p:sp>
       <p:sp>
         <p:nvSpPr>
-          <p:cNvPr id="57" name="Text 55"/>
+          <p:cNvPr id="59" name="Text 57"/>
           <p:cNvSpPr/>
           <p:nvPr/>
         </p:nvSpPr>
@@ -2819,7 +2900,7 @@
       </p:sp>
       <p:sp>
         <p:nvSpPr>
-          <p:cNvPr id="58" name="Shape 56"/>
+          <p:cNvPr id="60" name="Shape 58"/>
           <p:cNvSpPr/>
           <p:nvPr/>
         </p:nvSpPr>
@@ -2844,7 +2925,7 @@
       </p:sp>
       <p:sp>
         <p:nvSpPr>
-          <p:cNvPr id="59" name="Text 57"/>
+          <p:cNvPr id="61" name="Text 59"/>
           <p:cNvSpPr/>
           <p:nvPr/>
         </p:nvSpPr>
@@ -2875,7 +2956,7 @@
                 <a:ea typeface="Calibri" pitchFamily="34" charset="-122"/>
                 <a:cs typeface="Calibri" pitchFamily="34" charset="-120"/>
               </a:rPr>
-              <a:t>Pilot: CS Algorithms  │  Data: Credential Registry (CTDL)  │  Stack: FastAPI + React  │  Wharton/Gates Build-a-thon 2026</a:t>
+              <a:t>Pilot: CS Algorithms  │  Data: Credential Registry (CTDL)  │  Stack: FastAPI · React · Claude Haiku  │  Wharton/Gates Build-a-thon 2026</a:t>
             </a:r>
             <a:endParaRPr lang="en-US" sz="1100" dirty="0"/>
           </a:p>

</xml_diff>